<commit_message>
small prezentare scss update
</commit_message>
<xml_diff>
--- a/document/prezentare_scss.pptx
+++ b/document/prezentare_scss.pptx
@@ -23,7 +23,7 @@
   <p:notesSz cx="6858000" cy="9144000"/>
   <p:defaultTextStyle>
     <a:defPPr>
-      <a:defRPr lang="en-US"/>
+      <a:defRPr lang="ro-RO"/>
     </a:defPPr>
     <a:lvl1pPr marL="0" algn="l" defTabSz="914400" rtl="0">
       <a:defRPr sz="1800">
@@ -143,7 +143,7 @@
       </p:grpSpPr>
       <p:sp>
         <p:nvSpPr>
-          <p:cNvPr id="1373168393" name="Header Placeholder 1"/>
+          <p:cNvPr id="589144476" name="Header Placeholder 1"/>
           <p:cNvSpPr>
             <a:spLocks noGrp="1"/>
           </p:cNvSpPr>
@@ -177,7 +177,7 @@
       </p:sp>
       <p:sp>
         <p:nvSpPr>
-          <p:cNvPr id="1709276690" name="Date Placeholder 2"/>
+          <p:cNvPr id="176005339" name="Date Placeholder 2"/>
           <p:cNvSpPr>
             <a:spLocks noGrp="1"/>
           </p:cNvSpPr>
@@ -215,7 +215,7 @@
       </p:sp>
       <p:sp>
         <p:nvSpPr>
-          <p:cNvPr id="163351675" name="Slide Image Placeholder 3"/>
+          <p:cNvPr id="1151028761" name="Slide Image Placeholder 3"/>
           <p:cNvSpPr>
             <a:spLocks noChangeAspect="1" noGrp="1" noRot="1"/>
           </p:cNvSpPr>
@@ -251,7 +251,7 @@
       </p:sp>
       <p:sp>
         <p:nvSpPr>
-          <p:cNvPr id="352061009" name="Notes Placeholder 4"/>
+          <p:cNvPr id="1772437935" name="Notes Placeholder 4"/>
           <p:cNvSpPr>
             <a:spLocks noGrp="1"/>
           </p:cNvSpPr>
@@ -325,7 +325,7 @@
       </p:sp>
       <p:sp>
         <p:nvSpPr>
-          <p:cNvPr id="2141856099" name="Footer Placeholder 5"/>
+          <p:cNvPr id="1255701150" name="Footer Placeholder 5"/>
           <p:cNvSpPr>
             <a:spLocks noGrp="1"/>
           </p:cNvSpPr>
@@ -359,7 +359,7 @@
       </p:sp>
       <p:sp>
         <p:nvSpPr>
-          <p:cNvPr id="895297697" name="Slide Number Placeholder 6"/>
+          <p:cNvPr id="454968706" name="Slide Number Placeholder 6"/>
           <p:cNvSpPr>
             <a:spLocks noGrp="1"/>
           </p:cNvSpPr>
@@ -512,7 +512,7 @@
       </p:grpSpPr>
       <p:sp>
         <p:nvSpPr>
-          <p:cNvPr id="1876857248" name="Slide Image Placeholder 1"/>
+          <p:cNvPr id="1138225080" name="Slide Image Placeholder 1"/>
           <p:cNvSpPr>
             <a:spLocks noChangeAspect="1" noGrp="1" noRot="1"/>
           </p:cNvSpPr>
@@ -529,7 +529,7 @@
       </p:sp>
       <p:sp>
         <p:nvSpPr>
-          <p:cNvPr id="1025773333" name="Notes Placeholder 2"/>
+          <p:cNvPr id="2081290223" name="Notes Placeholder 2"/>
           <p:cNvSpPr>
             <a:spLocks noGrp="1"/>
           </p:cNvSpPr>
@@ -554,7 +554,7 @@
       </p:sp>
       <p:sp>
         <p:nvSpPr>
-          <p:cNvPr id="383824752" name="Slide Number Placeholder 3"/>
+          <p:cNvPr id="180781334" name="Slide Number Placeholder 3"/>
           <p:cNvSpPr>
             <a:spLocks noGrp="1"/>
           </p:cNvSpPr>
@@ -5329,7 +5329,7 @@
       </p:grpSpPr>
       <p:sp>
         <p:nvSpPr>
-          <p:cNvPr id="98286186" name="Title 1"/>
+          <p:cNvPr id="2036164413" name="Title 1"/>
           <p:cNvSpPr>
             <a:spLocks noGrp="1"/>
           </p:cNvSpPr>
@@ -5357,13 +5357,16 @@
                 <a:solidFill>
                   <a:srgbClr val="000000"/>
                 </a:solidFill>
-                <a:latin typeface="Times New Roman"/>
-                <a:ea typeface="Times New Roman"/>
-                <a:cs typeface="Times New Roman"/>
+                <a:latin typeface="Cantarell"/>
+                <a:ea typeface="Cantarell"/>
+                <a:cs typeface="Cantarell"/>
               </a:rPr>
               <a:t>Sistem pentru detecția și raportarea evenimentelor de</a:t>
             </a:r>
-            <a:endParaRPr sz="16000"/>
+            <a:endParaRPr sz="16000">
+              <a:latin typeface="Cantarell"/>
+              <a:cs typeface="Cantarell"/>
+            </a:endParaRPr>
           </a:p>
           <a:p>
             <a:pPr algn="ctr">
@@ -5374,19 +5377,22 @@
                 <a:solidFill>
                   <a:srgbClr val="000000"/>
                 </a:solidFill>
-                <a:latin typeface="Times New Roman"/>
-                <a:ea typeface="Times New Roman"/>
-                <a:cs typeface="Times New Roman"/>
+                <a:latin typeface="Cantarell"/>
+                <a:ea typeface="Cantarell"/>
+                <a:cs typeface="Cantarell"/>
               </a:rPr>
               <a:t>securitate în rețele industriale de comunicații.</a:t>
             </a:r>
-            <a:endParaRPr lang="en-US"/>
-          </a:p>
-        </p:txBody>
-      </p:sp>
-      <p:sp>
-        <p:nvSpPr>
-          <p:cNvPr id="1385523774" name="Subtitle 2"/>
+            <a:endParaRPr>
+              <a:latin typeface="Cantarell"/>
+              <a:cs typeface="Cantarell"/>
+            </a:endParaRPr>
+          </a:p>
+        </p:txBody>
+      </p:sp>
+      <p:sp>
+        <p:nvSpPr>
+          <p:cNvPr id="163809536" name="Subtitle 2"/>
           <p:cNvSpPr>
             <a:spLocks noGrp="1"/>
           </p:cNvSpPr>
@@ -5408,10 +5414,17 @@
               <a:defRPr/>
             </a:pPr>
             <a:r>
-              <a:rPr lang="en-US" sz="2600"/>
+              <a:rPr lang="en-US" sz="2600">
+                <a:latin typeface="Cantarell"/>
+                <a:ea typeface="Cantarell"/>
+                <a:cs typeface="Cantarell"/>
+              </a:rPr>
               <a:t>Theodor Predescu, grupa 342A1</a:t>
             </a:r>
-            <a:endParaRPr lang="en-US" sz="2600"/>
+            <a:endParaRPr sz="2600">
+              <a:latin typeface="Cantarell"/>
+              <a:cs typeface="Cantarell"/>
+            </a:endParaRPr>
           </a:p>
         </p:txBody>
       </p:sp>
@@ -5544,10 +5557,17 @@
               <a:defRPr/>
             </a:pPr>
             <a:r>
-              <a:rPr/>
+              <a:rPr>
+                <a:latin typeface="Cantarell"/>
+                <a:ea typeface="Cantarell"/>
+                <a:cs typeface="Cantarell"/>
+              </a:rPr>
               <a:t>Domeniul de lucru</a:t>
             </a:r>
-            <a:endParaRPr/>
+            <a:endParaRPr>
+              <a:latin typeface="Cantarell"/>
+              <a:cs typeface="Cantarell"/>
+            </a:endParaRPr>
           </a:p>
         </p:txBody>
       </p:sp>
@@ -5577,10 +5597,17 @@
               <a:defRPr/>
             </a:pPr>
             <a:r>
-              <a:rPr/>
+              <a:rPr>
+                <a:latin typeface="Cantarell"/>
+                <a:ea typeface="Cantarell"/>
+                <a:cs typeface="Cantarell"/>
+              </a:rPr>
               <a:t>Mediul industrial</a:t>
             </a:r>
-            <a:endParaRPr/>
+            <a:endParaRPr>
+              <a:latin typeface="Cantarell"/>
+              <a:cs typeface="Cantarell"/>
+            </a:endParaRPr>
           </a:p>
         </p:txBody>
       </p:sp>
@@ -5636,14 +5663,25 @@
               <a:defRPr/>
             </a:pPr>
             <a:r>
-              <a:rPr lang="ro-RO"/>
+              <a:rPr lang="ro-RO">
+                <a:latin typeface="Cantarell"/>
+                <a:ea typeface="Cantarell"/>
+                <a:cs typeface="Cantarell"/>
+              </a:rPr>
               <a:t>Problema adresat</a:t>
             </a:r>
             <a:r>
-              <a:rPr lang="ro-RO"/>
+              <a:rPr lang="ro-RO">
+                <a:latin typeface="Cantarell"/>
+                <a:ea typeface="Cantarell"/>
+                <a:cs typeface="Cantarell"/>
+              </a:rPr>
               <a:t>ă</a:t>
             </a:r>
-            <a:endParaRPr lang="ro-RO"/>
+            <a:endParaRPr>
+              <a:latin typeface="Cantarell"/>
+              <a:cs typeface="Cantarell"/>
+            </a:endParaRPr>
           </a:p>
         </p:txBody>
       </p:sp>
@@ -5657,7 +5695,12 @@
             <p:ph idx="1"/>
           </p:nvPr>
         </p:nvSpPr>
-        <p:spPr bwMode="auto"/>
+        <p:spPr bwMode="auto">
+          <a:xfrm flipH="0" flipV="0">
+            <a:off x="609599" y="2605548"/>
+            <a:ext cx="10972800" cy="3520615"/>
+          </a:xfrm>
+        </p:spPr>
         <p:txBody>
           <a:bodyPr/>
           <a:lstStyle/>
@@ -5668,10 +5711,33 @@
               <a:defRPr/>
             </a:pPr>
             <a:r>
-              <a:rPr lang="ro-RO"/>
+              <a:rPr lang="ro-RO">
+                <a:latin typeface="Cantarell"/>
+                <a:ea typeface="Cantarell"/>
+                <a:cs typeface="Cantarell"/>
+              </a:rPr>
               <a:t>Prevenirea intruziunilor</a:t>
             </a:r>
-            <a:endParaRPr lang="ro-RO"/>
+            <a:r>
+              <a:rPr lang="en-US">
+                <a:latin typeface="Cantarell"/>
+                <a:ea typeface="Cantarell"/>
+                <a:cs typeface="Cantarell"/>
+              </a:rPr>
+              <a:t> </a:t>
+            </a:r>
+            <a:r>
+              <a:rPr lang="ro-RO">
+                <a:latin typeface="Cantarell"/>
+                <a:ea typeface="Cantarell"/>
+                <a:cs typeface="Cantarell"/>
+              </a:rPr>
+              <a:t>pe dispozitive specifice</a:t>
+            </a:r>
+            <a:endParaRPr>
+              <a:latin typeface="Cantarell"/>
+              <a:cs typeface="Cantarell"/>
+            </a:endParaRPr>
           </a:p>
         </p:txBody>
       </p:sp>
@@ -5727,10 +5793,17 @@
               <a:defRPr/>
             </a:pPr>
             <a:r>
-              <a:rPr/>
-              <a:t>Solutia propusa</a:t>
-            </a:r>
-            <a:endParaRPr/>
+              <a:rPr>
+                <a:latin typeface="Cantarell"/>
+                <a:ea typeface="Cantarell"/>
+                <a:cs typeface="Cantarell"/>
+              </a:rPr>
+              <a:t>Soluția propusă</a:t>
+            </a:r>
+            <a:endParaRPr>
+              <a:latin typeface="Cantarell"/>
+              <a:cs typeface="Cantarell"/>
+            </a:endParaRPr>
           </a:p>
         </p:txBody>
       </p:sp>
@@ -5744,15 +5817,104 @@
             <p:ph idx="1"/>
           </p:nvPr>
         </p:nvSpPr>
-        <p:spPr bwMode="auto"/>
-        <p:txBody>
-          <a:bodyPr/>
-          <a:lstStyle/>
-          <a:p>
-            <a:pPr>
-              <a:defRPr/>
-            </a:pPr>
-            <a:endParaRPr/>
+        <p:spPr bwMode="auto">
+          <a:xfrm flipH="0" flipV="0">
+            <a:off x="609599" y="2513370"/>
+            <a:ext cx="10972800" cy="3612792"/>
+          </a:xfrm>
+        </p:spPr>
+        <p:txBody>
+          <a:bodyPr/>
+          <a:lstStyle/>
+          <a:p>
+            <a:pPr>
+              <a:defRPr/>
+            </a:pPr>
+            <a:r>
+              <a:rPr lang="ro-RO">
+                <a:latin typeface="Cantarell"/>
+                <a:ea typeface="Cantarell"/>
+                <a:cs typeface="Cantarell"/>
+              </a:rPr>
+              <a:t>Aplicație de monitorizare și</a:t>
+            </a:r>
+            <a:r>
+              <a:rPr lang="ro-RO">
+                <a:latin typeface="Cantarell"/>
+                <a:ea typeface="Cantarell"/>
+                <a:cs typeface="Cantarell"/>
+              </a:rPr>
+              <a:t> gestionare</a:t>
+            </a:r>
+            <a:r>
+              <a:rPr lang="ro-RO">
+                <a:latin typeface="Cantarell"/>
+                <a:ea typeface="Cantarell"/>
+                <a:cs typeface="Cantarell"/>
+              </a:rPr>
+              <a:t> a conexiunilor </a:t>
+            </a:r>
+            <a:r>
+              <a:rPr lang="ro-RO">
+                <a:latin typeface="Cantarell"/>
+                <a:ea typeface="Cantarell"/>
+                <a:cs typeface="Cantarell"/>
+              </a:rPr>
+              <a:t>  </a:t>
+            </a:r>
+            <a:r>
+              <a:rPr lang="ro-RO">
+                <a:latin typeface="Cantarell"/>
+                <a:ea typeface="Cantarell"/>
+                <a:cs typeface="Cantarell"/>
+              </a:rPr>
+              <a:t>într</a:t>
+            </a:r>
+            <a:r>
+              <a:rPr lang="ro-RO">
+                <a:latin typeface="Cantarell"/>
+                <a:ea typeface="Cantarell"/>
+                <a:cs typeface="Cantarell"/>
+              </a:rPr>
+              <a:t>-</a:t>
+            </a:r>
+            <a:r>
+              <a:rPr lang="ro-RO">
+                <a:latin typeface="Cantarell"/>
+                <a:ea typeface="Cantarell"/>
+                <a:cs typeface="Cantarell"/>
+              </a:rPr>
+              <a:t>o rețea</a:t>
+            </a:r>
+            <a:endParaRPr lang="ro-RO">
+              <a:latin typeface="Cantarell"/>
+              <a:cs typeface="Cantarell"/>
+            </a:endParaRPr>
+          </a:p>
+          <a:p>
+            <a:pPr>
+              <a:defRPr/>
+            </a:pPr>
+            <a:r>
+              <a:rPr lang="ro-RO">
+                <a:latin typeface="Cantarell"/>
+                <a:ea typeface="Cantarell"/>
+                <a:cs typeface="Cantarell"/>
+              </a:rPr>
+              <a:t>Soluție bazată pe </a:t>
+            </a:r>
+            <a:r>
+              <a:rPr lang="ro-RO">
+                <a:latin typeface="Cantarell"/>
+                <a:ea typeface="Cantarell"/>
+                <a:cs typeface="Cantarell"/>
+              </a:rPr>
+              <a:t>reguli</a:t>
+            </a:r>
+            <a:endParaRPr lang="ro-RO">
+              <a:latin typeface="Cantarell"/>
+              <a:cs typeface="Cantarell"/>
+            </a:endParaRPr>
           </a:p>
         </p:txBody>
       </p:sp>
@@ -5807,7 +5969,18 @@
             <a:pPr>
               <a:defRPr/>
             </a:pPr>
-            <a:endParaRPr/>
+            <a:r>
+              <a:rPr lang="ro-RO">
+                <a:latin typeface="Cantarell"/>
+                <a:ea typeface="Cantarell"/>
+                <a:cs typeface="Cantarell"/>
+              </a:rPr>
+              <a:t>Componente principale</a:t>
+            </a:r>
+            <a:endParaRPr>
+              <a:latin typeface="Cantarell"/>
+              <a:cs typeface="Cantarell"/>
+            </a:endParaRPr>
           </a:p>
         </p:txBody>
       </p:sp>
@@ -5821,15 +5994,111 @@
             <p:ph idx="1"/>
           </p:nvPr>
         </p:nvSpPr>
-        <p:spPr bwMode="auto"/>
-        <p:txBody>
-          <a:bodyPr/>
-          <a:lstStyle/>
-          <a:p>
-            <a:pPr>
-              <a:defRPr/>
-            </a:pPr>
-            <a:endParaRPr/>
+        <p:spPr bwMode="auto">
+          <a:xfrm flipH="0" flipV="0">
+            <a:off x="609599" y="2525661"/>
+            <a:ext cx="10972800" cy="3600502"/>
+          </a:xfrm>
+        </p:spPr>
+        <p:txBody>
+          <a:bodyPr/>
+          <a:lstStyle/>
+          <a:p>
+            <a:pPr marL="0" indent="0">
+              <a:buFont typeface="Arial"/>
+              <a:buNone/>
+              <a:defRPr/>
+            </a:pPr>
+            <a:r>
+              <a:rPr sz="3200" b="0" i="0" u="none">
+                <a:solidFill>
+                  <a:srgbClr val="000000"/>
+                </a:solidFill>
+                <a:latin typeface="Cantarell"/>
+                <a:ea typeface="Cantarell"/>
+                <a:cs typeface="Cantarell"/>
+              </a:rPr>
+              <a:t>1. componenta de filtrare la nivel kernel</a:t>
+            </a:r>
+            <a:endParaRPr sz="3200">
+              <a:latin typeface="Cantarell"/>
+              <a:cs typeface="Cantarell"/>
+            </a:endParaRPr>
+          </a:p>
+          <a:p>
+            <a:pPr marL="0" indent="0">
+              <a:buFont typeface="Arial"/>
+              <a:buNone/>
+              <a:defRPr/>
+            </a:pPr>
+            <a:r>
+              <a:rPr sz="3200" b="0" i="0" u="none">
+                <a:solidFill>
+                  <a:srgbClr val="000000"/>
+                </a:solidFill>
+                <a:latin typeface="Cantarell"/>
+                <a:ea typeface="Cantarell"/>
+                <a:cs typeface="Cantarell"/>
+              </a:rPr>
+              <a:t>2. componenta de intermediere</a:t>
+            </a:r>
+            <a:endParaRPr sz="3200">
+              <a:latin typeface="Cantarell"/>
+              <a:cs typeface="Cantarell"/>
+            </a:endParaRPr>
+          </a:p>
+          <a:p>
+            <a:pPr marL="0" indent="0">
+              <a:buFont typeface="Arial"/>
+              <a:buNone/>
+              <a:defRPr/>
+            </a:pPr>
+            <a:r>
+              <a:rPr sz="3200" b="0" i="0" u="none">
+                <a:solidFill>
+                  <a:srgbClr val="000000"/>
+                </a:solidFill>
+                <a:latin typeface="Cantarell"/>
+                <a:ea typeface="Cantarell"/>
+                <a:cs typeface="Cantarell"/>
+              </a:rPr>
+              <a:t>3. componenta centrală</a:t>
+            </a:r>
+            <a:endParaRPr sz="3200">
+              <a:latin typeface="Cantarell"/>
+              <a:cs typeface="Cantarell"/>
+            </a:endParaRPr>
+          </a:p>
+          <a:p>
+            <a:pPr marL="0" indent="0">
+              <a:buFont typeface="Arial"/>
+              <a:buNone/>
+              <a:defRPr/>
+            </a:pPr>
+            <a:r>
+              <a:rPr sz="3200" b="0" i="0" u="none">
+                <a:solidFill>
+                  <a:srgbClr val="000000"/>
+                </a:solidFill>
+                <a:latin typeface="Cantarell"/>
+                <a:ea typeface="Cantarell"/>
+                <a:cs typeface="Cantarell"/>
+              </a:rPr>
+              <a:t>4. componenta de administrare</a:t>
+            </a:r>
+            <a:endParaRPr sz="3200">
+              <a:latin typeface="Cantarell"/>
+              <a:cs typeface="Cantarell"/>
+            </a:endParaRPr>
+          </a:p>
+          <a:p>
+            <a:pPr>
+              <a:defRPr/>
+            </a:pPr>
+            <a:endParaRPr>
+              <a:latin typeface="Cantarell"/>
+              <a:cs typeface="Cantarell"/>
+            </a:endParaRPr>
           </a:p>
         </p:txBody>
       </p:sp>

</xml_diff>

<commit_message>
Just text added to the presentation scss
</commit_message>
<xml_diff>
--- a/document/prezentare_scss.pptx
+++ b/document/prezentare_scss.pptx
@@ -5,7 +5,7 @@
     <p:sldMasterId id="2147483648" r:id="rId1"/>
   </p:sldMasterIdLst>
   <p:notesMasterIdLst>
-    <p:notesMasterId r:id="rId14"/>
+    <p:notesMasterId r:id="rId12"/>
   </p:notesMasterIdLst>
   <p:sldIdLst>
     <p:sldId id="256" r:id="rId4"/>
@@ -16,8 +16,6 @@
     <p:sldId id="261" r:id="rId9"/>
     <p:sldId id="262" r:id="rId10"/>
     <p:sldId id="263" r:id="rId11"/>
-    <p:sldId id="264" r:id="rId12"/>
-    <p:sldId id="265" r:id="rId13"/>
   </p:sldIdLst>
   <p:sldSz cx="12192000" cy="6858000"/>
   <p:notesSz cx="6858000" cy="9144000"/>
@@ -143,7 +141,7 @@
       </p:grpSpPr>
       <p:sp>
         <p:nvSpPr>
-          <p:cNvPr id="589144476" name="Header Placeholder 1"/>
+          <p:cNvPr id="1516805500" name="Header Placeholder 1"/>
           <p:cNvSpPr>
             <a:spLocks noGrp="1"/>
           </p:cNvSpPr>
@@ -177,7 +175,7 @@
       </p:sp>
       <p:sp>
         <p:nvSpPr>
-          <p:cNvPr id="176005339" name="Date Placeholder 2"/>
+          <p:cNvPr id="1684285053" name="Date Placeholder 2"/>
           <p:cNvSpPr>
             <a:spLocks noGrp="1"/>
           </p:cNvSpPr>
@@ -215,7 +213,7 @@
       </p:sp>
       <p:sp>
         <p:nvSpPr>
-          <p:cNvPr id="1151028761" name="Slide Image Placeholder 3"/>
+          <p:cNvPr id="1113101882" name="Slide Image Placeholder 3"/>
           <p:cNvSpPr>
             <a:spLocks noChangeAspect="1" noGrp="1" noRot="1"/>
           </p:cNvSpPr>
@@ -251,7 +249,7 @@
       </p:sp>
       <p:sp>
         <p:nvSpPr>
-          <p:cNvPr id="1772437935" name="Notes Placeholder 4"/>
+          <p:cNvPr id="1313184887" name="Notes Placeholder 4"/>
           <p:cNvSpPr>
             <a:spLocks noGrp="1"/>
           </p:cNvSpPr>
@@ -325,7 +323,7 @@
       </p:sp>
       <p:sp>
         <p:nvSpPr>
-          <p:cNvPr id="1255701150" name="Footer Placeholder 5"/>
+          <p:cNvPr id="1040689979" name="Footer Placeholder 5"/>
           <p:cNvSpPr>
             <a:spLocks noGrp="1"/>
           </p:cNvSpPr>
@@ -359,7 +357,7 @@
       </p:sp>
       <p:sp>
         <p:nvSpPr>
-          <p:cNvPr id="454968706" name="Slide Number Placeholder 6"/>
+          <p:cNvPr id="2108252570" name="Slide Number Placeholder 6"/>
           <p:cNvSpPr>
             <a:spLocks noGrp="1"/>
           </p:cNvSpPr>
@@ -512,7 +510,7 @@
       </p:grpSpPr>
       <p:sp>
         <p:nvSpPr>
-          <p:cNvPr id="1138225080" name="Slide Image Placeholder 1"/>
+          <p:cNvPr id="1455957014" name="Slide Image Placeholder 1"/>
           <p:cNvSpPr>
             <a:spLocks noChangeAspect="1" noGrp="1" noRot="1"/>
           </p:cNvSpPr>
@@ -529,7 +527,7 @@
       </p:sp>
       <p:sp>
         <p:nvSpPr>
-          <p:cNvPr id="2081290223" name="Notes Placeholder 2"/>
+          <p:cNvPr id="279129545" name="Notes Placeholder 2"/>
           <p:cNvSpPr>
             <a:spLocks noGrp="1"/>
           </p:cNvSpPr>
@@ -554,7 +552,7 @@
       </p:sp>
       <p:sp>
         <p:nvSpPr>
-          <p:cNvPr id="180781334" name="Slide Number Placeholder 3"/>
+          <p:cNvPr id="1758911899" name="Slide Number Placeholder 3"/>
           <p:cNvSpPr>
             <a:spLocks noGrp="1"/>
           </p:cNvSpPr>
@@ -575,91 +573,6 @@
               <a:t>1</a:t>
             </a:fld>
             <a:endParaRPr lang="en-US"/>
-          </a:p>
-        </p:txBody>
-      </p:sp>
-    </p:spTree>
-  </p:cSld>
-  <p:clrMapOvr>
-    <a:masterClrMapping/>
-  </p:clrMapOvr>
-</p:notes>
-</file>
-
-<file path=ppt/notesSlides/notesSlide10.xml><?xml version="1.0" encoding="utf-8"?>
-<p:notes xmlns:a="http://schemas.openxmlformats.org/drawingml/2006/main" xmlns:r="http://schemas.openxmlformats.org/officeDocument/2006/relationships" xmlns:p="http://schemas.openxmlformats.org/presentationml/2006/main" xmlns:m="http://schemas.openxmlformats.org/officeDocument/2006/math" xmlns:w="http://schemas.openxmlformats.org/wordprocessingml/2006/main">
-  <p:cSld name="">
-    <p:spTree>
-      <p:nvGrpSpPr>
-        <p:cNvPr id="1" name=""/>
-        <p:cNvGrpSpPr/>
-        <p:nvPr/>
-      </p:nvGrpSpPr>
-      <p:grpSpPr bwMode="auto">
-        <a:xfrm>
-          <a:off x="0" y="0"/>
-          <a:ext cx="0" cy="0"/>
-          <a:chOff x="0" y="0"/>
-          <a:chExt cx="0" cy="0"/>
-        </a:xfrm>
-      </p:grpSpPr>
-      <p:sp>
-        <p:nvSpPr>
-          <p:cNvPr id="873803961" name="Slide Image Placeholder 1"/>
-          <p:cNvSpPr>
-            <a:spLocks noChangeAspect="1" noGrp="1" noRot="1"/>
-          </p:cNvSpPr>
-          <p:nvPr>
-            <p:ph type="sldImg"/>
-          </p:nvPr>
-        </p:nvSpPr>
-        <p:spPr bwMode="auto"/>
-      </p:sp>
-      <p:sp>
-        <p:nvSpPr>
-          <p:cNvPr id="1603295819" name="Notes Placeholder 2"/>
-          <p:cNvSpPr>
-            <a:spLocks noGrp="1"/>
-          </p:cNvSpPr>
-          <p:nvPr>
-            <p:ph type="body" idx="1"/>
-          </p:nvPr>
-        </p:nvSpPr>
-        <p:spPr bwMode="auto"/>
-        <p:txBody>
-          <a:bodyPr/>
-          <a:lstStyle/>
-          <a:p>
-            <a:pPr>
-              <a:defRPr/>
-            </a:pPr>
-            <a:endParaRPr/>
-          </a:p>
-        </p:txBody>
-      </p:sp>
-      <p:sp>
-        <p:nvSpPr>
-          <p:cNvPr id="1963930928" name="Slide Number Placeholder 3"/>
-          <p:cNvSpPr>
-            <a:spLocks noGrp="1"/>
-          </p:cNvSpPr>
-          <p:nvPr>
-            <p:ph type="sldNum" sz="quarter" idx="10"/>
-          </p:nvPr>
-        </p:nvSpPr>
-        <p:spPr bwMode="auto"/>
-        <p:txBody>
-          <a:bodyPr/>
-          <a:lstStyle/>
-          <a:p>
-            <a:pPr>
-              <a:defRPr/>
-            </a:pPr>
-            <a:fld id="{434D16DC-48C4-E168-F952-82C669E57C14}" type="slidenum">
-              <a:rPr/>
-              <a:t/>
-            </a:fld>
-            <a:endParaRPr/>
           </a:p>
         </p:txBody>
       </p:sp>
@@ -1251,91 +1164,6 @@
               <a:defRPr/>
             </a:pPr>
             <a:fld id="{B176B3BA-0FDF-4629-213E-EC55DE52E198}" type="slidenum">
-              <a:rPr/>
-              <a:t/>
-            </a:fld>
-            <a:endParaRPr/>
-          </a:p>
-        </p:txBody>
-      </p:sp>
-    </p:spTree>
-  </p:cSld>
-  <p:clrMapOvr>
-    <a:masterClrMapping/>
-  </p:clrMapOvr>
-</p:notes>
-</file>
-
-<file path=ppt/notesSlides/notesSlide9.xml><?xml version="1.0" encoding="utf-8"?>
-<p:notes xmlns:a="http://schemas.openxmlformats.org/drawingml/2006/main" xmlns:r="http://schemas.openxmlformats.org/officeDocument/2006/relationships" xmlns:p="http://schemas.openxmlformats.org/presentationml/2006/main" xmlns:m="http://schemas.openxmlformats.org/officeDocument/2006/math" xmlns:w="http://schemas.openxmlformats.org/wordprocessingml/2006/main">
-  <p:cSld name="">
-    <p:spTree>
-      <p:nvGrpSpPr>
-        <p:cNvPr id="1" name=""/>
-        <p:cNvGrpSpPr/>
-        <p:nvPr/>
-      </p:nvGrpSpPr>
-      <p:grpSpPr bwMode="auto">
-        <a:xfrm>
-          <a:off x="0" y="0"/>
-          <a:ext cx="0" cy="0"/>
-          <a:chOff x="0" y="0"/>
-          <a:chExt cx="0" cy="0"/>
-        </a:xfrm>
-      </p:grpSpPr>
-      <p:sp>
-        <p:nvSpPr>
-          <p:cNvPr id="1910948014" name="Slide Image Placeholder 1"/>
-          <p:cNvSpPr>
-            <a:spLocks noChangeAspect="1" noGrp="1" noRot="1"/>
-          </p:cNvSpPr>
-          <p:nvPr>
-            <p:ph type="sldImg"/>
-          </p:nvPr>
-        </p:nvSpPr>
-        <p:spPr bwMode="auto"/>
-      </p:sp>
-      <p:sp>
-        <p:nvSpPr>
-          <p:cNvPr id="1987287872" name="Notes Placeholder 2"/>
-          <p:cNvSpPr>
-            <a:spLocks noGrp="1"/>
-          </p:cNvSpPr>
-          <p:nvPr>
-            <p:ph type="body" idx="1"/>
-          </p:nvPr>
-        </p:nvSpPr>
-        <p:spPr bwMode="auto"/>
-        <p:txBody>
-          <a:bodyPr/>
-          <a:lstStyle/>
-          <a:p>
-            <a:pPr>
-              <a:defRPr/>
-            </a:pPr>
-            <a:endParaRPr/>
-          </a:p>
-        </p:txBody>
-      </p:sp>
-      <p:sp>
-        <p:nvSpPr>
-          <p:cNvPr id="501638714" name="Slide Number Placeholder 3"/>
-          <p:cNvSpPr>
-            <a:spLocks noGrp="1"/>
-          </p:cNvSpPr>
-          <p:nvPr>
-            <p:ph type="sldNum" sz="quarter" idx="10"/>
-          </p:nvPr>
-        </p:nvSpPr>
-        <p:spPr bwMode="auto"/>
-        <p:txBody>
-          <a:bodyPr/>
-          <a:lstStyle/>
-          <a:p>
-            <a:pPr>
-              <a:defRPr/>
-            </a:pPr>
-            <a:fld id="{5BEB0E07-5276-E1CC-C77A-ECA5A646B1CB}" type="slidenum">
               <a:rPr/>
               <a:t/>
             </a:fld>
@@ -5329,7 +5157,7 @@
       </p:grpSpPr>
       <p:sp>
         <p:nvSpPr>
-          <p:cNvPr id="2036164413" name="Title 1"/>
+          <p:cNvPr id="102744156" name="Title 1"/>
           <p:cNvSpPr>
             <a:spLocks noGrp="1"/>
           </p:cNvSpPr>
@@ -5392,7 +5220,7 @@
       </p:sp>
       <p:sp>
         <p:nvSpPr>
-          <p:cNvPr id="163809536" name="Subtitle 2"/>
+          <p:cNvPr id="823749719" name="Subtitle 2"/>
           <p:cNvSpPr>
             <a:spLocks noGrp="1"/>
           </p:cNvSpPr>
@@ -5414,94 +5242,17 @@
               <a:defRPr/>
             </a:pPr>
             <a:r>
-              <a:rPr lang="en-US" sz="2600">
+              <a:rPr lang="ro-RO" sz="2600">
                 <a:latin typeface="Cantarell"/>
                 <a:ea typeface="Cantarell"/>
                 <a:cs typeface="Cantarell"/>
               </a:rPr>
               <a:t>Theodor Predescu, grupa 342A1</a:t>
             </a:r>
-            <a:endParaRPr sz="2600">
+            <a:endParaRPr lang="ro-RO" sz="2600">
               <a:latin typeface="Cantarell"/>
               <a:cs typeface="Cantarell"/>
             </a:endParaRPr>
-          </a:p>
-        </p:txBody>
-      </p:sp>
-    </p:spTree>
-  </p:cSld>
-  <p:clrMapOvr>
-    <a:masterClrMapping/>
-  </p:clrMapOvr>
-  <mc:AlternateContent xmlns:mc="http://schemas.openxmlformats.org/markup-compatibility/2006">
-    <mc:Choice xmlns:p159="http://schemas.microsoft.com/office/powerpoint/2015/09/main" xmlns:p14="http://schemas.microsoft.com/office/powerpoint/2010/main" Requires="p159">
-      <p:transition p14:dur="500" advClick="1"/>
-    </mc:Choice>
-    <mc:Fallback>
-      <p:transition advClick="1"/>
-    </mc:Fallback>
-  </mc:AlternateContent>
-</p:sld>
-</file>
-
-<file path=ppt/slides/slide10.xml><?xml version="1.0" encoding="utf-8"?>
-<p:sld xmlns:a="http://schemas.openxmlformats.org/drawingml/2006/main" xmlns:r="http://schemas.openxmlformats.org/officeDocument/2006/relationships" xmlns:p="http://schemas.openxmlformats.org/presentationml/2006/main" xmlns:m="http://schemas.openxmlformats.org/officeDocument/2006/math" xmlns:w="http://schemas.openxmlformats.org/wordprocessingml/2006/main" xmlns:mc="http://schemas.openxmlformats.org/markup-compatibility/2006" showMasterPhAnim="0" showMasterSp="1" show="1">
-  <p:cSld name="">
-    <p:spTree>
-      <p:nvGrpSpPr>
-        <p:cNvPr id="1" name=""/>
-        <p:cNvGrpSpPr/>
-        <p:nvPr/>
-      </p:nvGrpSpPr>
-      <p:grpSpPr bwMode="auto">
-        <a:xfrm>
-          <a:off x="0" y="0"/>
-          <a:ext cx="0" cy="0"/>
-          <a:chOff x="0" y="0"/>
-          <a:chExt cx="0" cy="0"/>
-        </a:xfrm>
-      </p:grpSpPr>
-      <p:sp>
-        <p:nvSpPr>
-          <p:cNvPr id="14435055" name="Title 1"/>
-          <p:cNvSpPr>
-            <a:spLocks noGrp="1"/>
-          </p:cNvSpPr>
-          <p:nvPr>
-            <p:ph type="title"/>
-          </p:nvPr>
-        </p:nvSpPr>
-        <p:spPr bwMode="auto"/>
-        <p:txBody>
-          <a:bodyPr/>
-          <a:lstStyle/>
-          <a:p>
-            <a:pPr>
-              <a:defRPr/>
-            </a:pPr>
-            <a:endParaRPr/>
-          </a:p>
-        </p:txBody>
-      </p:sp>
-      <p:sp>
-        <p:nvSpPr>
-          <p:cNvPr id="1682994367" name="Content Placeholder 2"/>
-          <p:cNvSpPr>
-            <a:spLocks noGrp="1"/>
-          </p:cNvSpPr>
-          <p:nvPr>
-            <p:ph idx="1"/>
-          </p:nvPr>
-        </p:nvSpPr>
-        <p:spPr bwMode="auto"/>
-        <p:txBody>
-          <a:bodyPr/>
-          <a:lstStyle/>
-          <a:p>
-            <a:pPr>
-              <a:defRPr/>
-            </a:pPr>
-            <a:endParaRPr/>
           </a:p>
         </p:txBody>
       </p:sp>
@@ -6012,7 +5763,7 @@
             <a:r>
               <a:rPr sz="3200" b="0" i="0" u="none">
                 <a:solidFill>
-                  <a:srgbClr val="000000"/>
+                  <a:srgbClr val="404040"/>
                 </a:solidFill>
                 <a:latin typeface="Cantarell"/>
                 <a:ea typeface="Cantarell"/>
@@ -6021,6 +5772,9 @@
               <a:t>1. componenta de filtrare la nivel kernel</a:t>
             </a:r>
             <a:endParaRPr sz="3200">
+              <a:solidFill>
+                <a:srgbClr val="404040"/>
+              </a:solidFill>
               <a:latin typeface="Cantarell"/>
               <a:cs typeface="Cantarell"/>
             </a:endParaRPr>
@@ -6034,7 +5788,7 @@
             <a:r>
               <a:rPr sz="3200" b="0" i="0" u="none">
                 <a:solidFill>
-                  <a:srgbClr val="000000"/>
+                  <a:srgbClr val="404040"/>
                 </a:solidFill>
                 <a:latin typeface="Cantarell"/>
                 <a:ea typeface="Cantarell"/>
@@ -6043,6 +5797,9 @@
               <a:t>2. componenta de intermediere</a:t>
             </a:r>
             <a:endParaRPr sz="3200">
+              <a:solidFill>
+                <a:srgbClr val="404040"/>
+              </a:solidFill>
               <a:latin typeface="Cantarell"/>
               <a:cs typeface="Cantarell"/>
             </a:endParaRPr>
@@ -6056,7 +5813,7 @@
             <a:r>
               <a:rPr sz="3200" b="0" i="0" u="none">
                 <a:solidFill>
-                  <a:srgbClr val="000000"/>
+                  <a:srgbClr val="404040"/>
                 </a:solidFill>
                 <a:latin typeface="Cantarell"/>
                 <a:ea typeface="Cantarell"/>
@@ -6065,6 +5822,9 @@
               <a:t>3. componenta centrală</a:t>
             </a:r>
             <a:endParaRPr sz="3200">
+              <a:solidFill>
+                <a:srgbClr val="404040"/>
+              </a:solidFill>
               <a:latin typeface="Cantarell"/>
               <a:cs typeface="Cantarell"/>
             </a:endParaRPr>
@@ -6078,7 +5838,7 @@
             <a:r>
               <a:rPr sz="3200" b="0" i="0" u="none">
                 <a:solidFill>
-                  <a:srgbClr val="000000"/>
+                  <a:srgbClr val="404040"/>
                 </a:solidFill>
                 <a:latin typeface="Cantarell"/>
                 <a:ea typeface="Cantarell"/>
@@ -6087,6 +5847,9 @@
               <a:t>4. componenta de administrare</a:t>
             </a:r>
             <a:endParaRPr sz="3200">
+              <a:solidFill>
+                <a:srgbClr val="404040"/>
+              </a:solidFill>
               <a:latin typeface="Cantarell"/>
               <a:cs typeface="Cantarell"/>
             </a:endParaRPr>
@@ -6096,6 +5859,9 @@
               <a:defRPr/>
             </a:pPr>
             <a:endParaRPr>
+              <a:solidFill>
+                <a:srgbClr val="404040"/>
+              </a:solidFill>
               <a:latin typeface="Cantarell"/>
               <a:cs typeface="Cantarell"/>
             </a:endParaRPr>
@@ -6153,6 +5919,10 @@
             <a:pPr>
               <a:defRPr/>
             </a:pPr>
+            <a:r>
+              <a:rPr/>
+              <a:t>Cum funcționează ?</a:t>
+            </a:r>
             <a:endParaRPr/>
           </a:p>
         </p:txBody>
@@ -6167,10 +5937,53 @@
             <p:ph idx="1"/>
           </p:nvPr>
         </p:nvSpPr>
-        <p:spPr bwMode="auto"/>
-        <p:txBody>
-          <a:bodyPr/>
-          <a:lstStyle/>
+        <p:spPr bwMode="auto">
+          <a:xfrm flipH="0" flipV="0">
+            <a:off x="609599" y="2832919"/>
+            <a:ext cx="10972800" cy="2826774"/>
+          </a:xfrm>
+        </p:spPr>
+        <p:txBody>
+          <a:bodyPr/>
+          <a:lstStyle/>
+          <a:p>
+            <a:pPr>
+              <a:defRPr/>
+            </a:pPr>
+            <a:r>
+              <a:rPr/>
+              <a:t>Aplicarea regulilor alese pe echipament</a:t>
+            </a:r>
+            <a:endParaRPr/>
+          </a:p>
+          <a:p>
+            <a:pPr>
+              <a:defRPr/>
+            </a:pPr>
+            <a:r>
+              <a:rPr>
+                <a:solidFill>
+                  <a:srgbClr val="404040"/>
+                </a:solidFill>
+              </a:rPr>
+              <a:t>Extragerea </a:t>
+            </a:r>
+            <a:r>
+              <a:rPr/>
+              <a:t>și vizualizarea conexiunilor în mod grafic</a:t>
+            </a:r>
+            <a:endParaRPr/>
+          </a:p>
+          <a:p>
+            <a:pPr>
+              <a:defRPr/>
+            </a:pPr>
+            <a:r>
+              <a:rPr/>
+              <a:t>Modificarea acestora în timp real</a:t>
+            </a:r>
+            <a:endParaRPr/>
+          </a:p>
           <a:p>
             <a:pPr>
               <a:defRPr/>
@@ -6214,7 +6027,7 @@
       </p:grpSpPr>
       <p:sp>
         <p:nvSpPr>
-          <p:cNvPr id="1642416261" name="Title 1"/>
+          <p:cNvPr id="1615936370" name="Title 1"/>
           <p:cNvSpPr>
             <a:spLocks noGrp="1"/>
           </p:cNvSpPr>
@@ -6222,36 +6035,23 @@
             <p:ph type="title"/>
           </p:nvPr>
         </p:nvSpPr>
-        <p:spPr bwMode="auto"/>
-        <p:txBody>
-          <a:bodyPr/>
-          <a:lstStyle/>
-          <a:p>
-            <a:pPr>
-              <a:defRPr/>
-            </a:pPr>
-            <a:endParaRPr/>
-          </a:p>
-        </p:txBody>
-      </p:sp>
-      <p:sp>
-        <p:nvSpPr>
-          <p:cNvPr id="728406350" name="Content Placeholder 2"/>
-          <p:cNvSpPr>
-            <a:spLocks noGrp="1"/>
-          </p:cNvSpPr>
-          <p:nvPr>
-            <p:ph idx="1"/>
-          </p:nvPr>
-        </p:nvSpPr>
-        <p:spPr bwMode="auto"/>
-        <p:txBody>
-          <a:bodyPr/>
-          <a:lstStyle/>
-          <a:p>
-            <a:pPr>
-              <a:defRPr/>
-            </a:pPr>
+        <p:spPr bwMode="auto">
+          <a:xfrm>
+            <a:off x="609599" y="1515961"/>
+            <a:ext cx="10972800" cy="1143000"/>
+          </a:xfrm>
+        </p:spPr>
+        <p:txBody>
+          <a:bodyPr/>
+          <a:lstStyle/>
+          <a:p>
+            <a:pPr algn="ctr">
+              <a:defRPr/>
+            </a:pPr>
+            <a:r>
+              <a:rPr/>
+              <a:t>DEMO</a:t>
+            </a:r>
             <a:endParaRPr/>
           </a:p>
         </p:txBody>
@@ -6291,7 +6091,7 @@
       </p:grpSpPr>
       <p:sp>
         <p:nvSpPr>
-          <p:cNvPr id="625351513" name="Title 1"/>
+          <p:cNvPr id="975787259" name="Title 1"/>
           <p:cNvSpPr>
             <a:spLocks noGrp="1"/>
           </p:cNvSpPr>
@@ -6299,113 +6099,23 @@
             <p:ph type="title"/>
           </p:nvPr>
         </p:nvSpPr>
-        <p:spPr bwMode="auto"/>
-        <p:txBody>
-          <a:bodyPr/>
-          <a:lstStyle/>
-          <a:p>
-            <a:pPr>
-              <a:defRPr/>
-            </a:pPr>
-            <a:endParaRPr/>
-          </a:p>
-        </p:txBody>
-      </p:sp>
-      <p:sp>
-        <p:nvSpPr>
-          <p:cNvPr id="1891837290" name="Content Placeholder 2"/>
-          <p:cNvSpPr>
-            <a:spLocks noGrp="1"/>
-          </p:cNvSpPr>
-          <p:nvPr>
-            <p:ph idx="1"/>
-          </p:nvPr>
-        </p:nvSpPr>
-        <p:spPr bwMode="auto"/>
-        <p:txBody>
-          <a:bodyPr/>
-          <a:lstStyle/>
-          <a:p>
-            <a:pPr>
-              <a:defRPr/>
-            </a:pPr>
-            <a:endParaRPr/>
-          </a:p>
-        </p:txBody>
-      </p:sp>
-    </p:spTree>
-  </p:cSld>
-  <p:clrMapOvr>
-    <a:masterClrMapping/>
-  </p:clrMapOvr>
-  <mc:AlternateContent xmlns:mc="http://schemas.openxmlformats.org/markup-compatibility/2006">
-    <mc:Choice xmlns:p159="http://schemas.microsoft.com/office/powerpoint/2015/09/main" xmlns:p14="http://schemas.microsoft.com/office/powerpoint/2010/main" Requires="p159">
-      <p:transition p14:dur="500" advClick="1"/>
-    </mc:Choice>
-    <mc:Fallback>
-      <p:transition advClick="1"/>
-    </mc:Fallback>
-  </mc:AlternateContent>
-</p:sld>
-</file>
-
-<file path=ppt/slides/slide9.xml><?xml version="1.0" encoding="utf-8"?>
-<p:sld xmlns:a="http://schemas.openxmlformats.org/drawingml/2006/main" xmlns:r="http://schemas.openxmlformats.org/officeDocument/2006/relationships" xmlns:p="http://schemas.openxmlformats.org/presentationml/2006/main" xmlns:m="http://schemas.openxmlformats.org/officeDocument/2006/math" xmlns:w="http://schemas.openxmlformats.org/wordprocessingml/2006/main" xmlns:mc="http://schemas.openxmlformats.org/markup-compatibility/2006" showMasterPhAnim="0" showMasterSp="1" show="1">
-  <p:cSld name="">
-    <p:spTree>
-      <p:nvGrpSpPr>
-        <p:cNvPr id="1" name=""/>
-        <p:cNvGrpSpPr/>
-        <p:nvPr/>
-      </p:nvGrpSpPr>
-      <p:grpSpPr bwMode="auto">
-        <a:xfrm>
-          <a:off x="0" y="0"/>
-          <a:ext cx="0" cy="0"/>
-          <a:chOff x="0" y="0"/>
-          <a:chExt cx="0" cy="0"/>
-        </a:xfrm>
-      </p:grpSpPr>
-      <p:sp>
-        <p:nvSpPr>
-          <p:cNvPr id="1691871409" name="Title 1"/>
-          <p:cNvSpPr>
-            <a:spLocks noGrp="1"/>
-          </p:cNvSpPr>
-          <p:nvPr>
-            <p:ph type="title"/>
-          </p:nvPr>
-        </p:nvSpPr>
-        <p:spPr bwMode="auto"/>
-        <p:txBody>
-          <a:bodyPr/>
-          <a:lstStyle/>
-          <a:p>
-            <a:pPr>
-              <a:defRPr/>
-            </a:pPr>
-            <a:endParaRPr/>
-          </a:p>
-        </p:txBody>
-      </p:sp>
-      <p:sp>
-        <p:nvSpPr>
-          <p:cNvPr id="1627095299" name="Content Placeholder 2"/>
-          <p:cNvSpPr>
-            <a:spLocks noGrp="1"/>
-          </p:cNvSpPr>
-          <p:nvPr>
-            <p:ph idx="1"/>
-          </p:nvPr>
-        </p:nvSpPr>
-        <p:spPr bwMode="auto"/>
-        <p:txBody>
-          <a:bodyPr/>
-          <a:lstStyle/>
-          <a:p>
-            <a:pPr>
-              <a:defRPr/>
-            </a:pPr>
+        <p:spPr bwMode="auto">
+          <a:xfrm>
+            <a:off x="609599" y="2026009"/>
+            <a:ext cx="10972800" cy="1143000"/>
+          </a:xfrm>
+        </p:spPr>
+        <p:txBody>
+          <a:bodyPr/>
+          <a:lstStyle/>
+          <a:p>
+            <a:pPr algn="ctr">
+              <a:defRPr/>
+            </a:pPr>
+            <a:r>
+              <a:rPr/>
+              <a:t>Vă mulțumesc!</a:t>
+            </a:r>
             <a:endParaRPr/>
           </a:p>
         </p:txBody>

</xml_diff>